<commit_message>
Fix blacked-out snapshot and video placeholders
Replace near-black (#333333 / #2A2A2A) thumbnail fills with warm light
gray (#D6CFC4) so image/video placeholders are visible instead of
appearing as solid black boxes.

Co-Authored-By: Claude Sonnet 4.6 <noreply@anthropic.com>
Claude-Session: https://claude.ai/code/session_01AukWEhPkYUJBcaoSwPdTDM
</commit_message>
<xml_diff>
--- a/DriveHub_AutoHub_Portfolio.pptx
+++ b/DriveHub_AutoHub_Portfolio.pptx
@@ -3244,11 +3244,11 @@
             <a:avLst/>
           </a:prstGeom>
           <a:solidFill>
-            <a:srgbClr val="333333"/>
+            <a:srgbClr val="D6CFC4"/>
           </a:solidFill>
           <a:ln w="12700">
             <a:solidFill>
-              <a:srgbClr val="444444"/>
+              <a:srgbClr val="C0B8AA"/>
             </a:solidFill>
             <a:prstDash val="solid"/>
           </a:ln>
@@ -3436,11 +3436,11 @@
             <a:avLst/>
           </a:prstGeom>
           <a:solidFill>
-            <a:srgbClr val="333333"/>
+            <a:srgbClr val="D6CFC4"/>
           </a:solidFill>
           <a:ln w="12700">
             <a:solidFill>
-              <a:srgbClr val="444444"/>
+              <a:srgbClr val="C0B8AA"/>
             </a:solidFill>
             <a:prstDash val="solid"/>
           </a:ln>
@@ -3628,11 +3628,11 @@
             <a:avLst/>
           </a:prstGeom>
           <a:solidFill>
-            <a:srgbClr val="333333"/>
+            <a:srgbClr val="D6CFC4"/>
           </a:solidFill>
           <a:ln w="12700">
             <a:solidFill>
-              <a:srgbClr val="444444"/>
+              <a:srgbClr val="C0B8AA"/>
             </a:solidFill>
             <a:prstDash val="solid"/>
           </a:ln>
@@ -4496,11 +4496,11 @@
             <a:avLst/>
           </a:prstGeom>
           <a:solidFill>
-            <a:srgbClr val="333333"/>
+            <a:srgbClr val="D6CFC4"/>
           </a:solidFill>
           <a:ln w="12700">
             <a:solidFill>
-              <a:srgbClr val="444444"/>
+              <a:srgbClr val="C0B8AA"/>
             </a:solidFill>
             <a:prstDash val="solid"/>
           </a:ln>
@@ -4727,11 +4727,11 @@
             <a:avLst/>
           </a:prstGeom>
           <a:solidFill>
-            <a:srgbClr val="333333"/>
+            <a:srgbClr val="D6CFC4"/>
           </a:solidFill>
           <a:ln w="12700">
             <a:solidFill>
-              <a:srgbClr val="444444"/>
+              <a:srgbClr val="C0B8AA"/>
             </a:solidFill>
             <a:prstDash val="solid"/>
           </a:ln>
@@ -6396,11 +6396,11 @@
             <a:avLst/>
           </a:prstGeom>
           <a:solidFill>
-            <a:srgbClr val="2A2A2A"/>
+            <a:srgbClr val="D6CFC4"/>
           </a:solidFill>
           <a:ln w="12700">
             <a:solidFill>
-              <a:srgbClr val="444444"/>
+              <a:srgbClr val="C0B8AA"/>
             </a:solidFill>
             <a:prstDash val="solid"/>
           </a:ln>
@@ -6421,11 +6421,11 @@
             <a:avLst/>
           </a:prstGeom>
           <a:solidFill>
-            <a:srgbClr val="000000"/>
+            <a:srgbClr val="BFB8AF"/>
           </a:solidFill>
           <a:ln w="12700">
             <a:solidFill>
-              <a:srgbClr val="000000"/>
+              <a:srgbClr val="BFB8AF"/>
             </a:solidFill>
             <a:prstDash val="solid"/>
           </a:ln>
@@ -6541,11 +6541,11 @@
             <a:avLst/>
           </a:prstGeom>
           <a:solidFill>
-            <a:srgbClr val="2A2A2A"/>
+            <a:srgbClr val="D6CFC4"/>
           </a:solidFill>
           <a:ln w="12700">
             <a:solidFill>
-              <a:srgbClr val="444444"/>
+              <a:srgbClr val="C0B8AA"/>
             </a:solidFill>
             <a:prstDash val="solid"/>
           </a:ln>
@@ -6566,11 +6566,11 @@
             <a:avLst/>
           </a:prstGeom>
           <a:solidFill>
-            <a:srgbClr val="000000"/>
+            <a:srgbClr val="BFB8AF"/>
           </a:solidFill>
           <a:ln w="12700">
             <a:solidFill>
-              <a:srgbClr val="000000"/>
+              <a:srgbClr val="BFB8AF"/>
             </a:solidFill>
             <a:prstDash val="solid"/>
           </a:ln>
@@ -6686,11 +6686,11 @@
             <a:avLst/>
           </a:prstGeom>
           <a:solidFill>
-            <a:srgbClr val="2A2A2A"/>
+            <a:srgbClr val="D6CFC4"/>
           </a:solidFill>
           <a:ln w="12700">
             <a:solidFill>
-              <a:srgbClr val="444444"/>
+              <a:srgbClr val="C0B8AA"/>
             </a:solidFill>
             <a:prstDash val="solid"/>
           </a:ln>
@@ -6711,11 +6711,11 @@
             <a:avLst/>
           </a:prstGeom>
           <a:solidFill>
-            <a:srgbClr val="000000"/>
+            <a:srgbClr val="BFB8AF"/>
           </a:solidFill>
           <a:ln w="12700">
             <a:solidFill>
-              <a:srgbClr val="000000"/>
+              <a:srgbClr val="BFB8AF"/>
             </a:solidFill>
             <a:prstDash val="solid"/>
           </a:ln>
@@ -7344,11 +7344,11 @@
             <a:avLst/>
           </a:prstGeom>
           <a:solidFill>
-            <a:srgbClr val="2A2A2A"/>
+            <a:srgbClr val="D6CFC4"/>
           </a:solidFill>
           <a:ln w="12700">
             <a:solidFill>
-              <a:srgbClr val="444444"/>
+              <a:srgbClr val="C0B8AA"/>
             </a:solidFill>
             <a:prstDash val="solid"/>
           </a:ln>
@@ -7369,11 +7369,11 @@
             <a:avLst/>
           </a:prstGeom>
           <a:solidFill>
-            <a:srgbClr val="000000"/>
+            <a:srgbClr val="BFB8AF"/>
           </a:solidFill>
           <a:ln w="12700">
             <a:solidFill>
-              <a:srgbClr val="000000"/>
+              <a:srgbClr val="BFB8AF"/>
             </a:solidFill>
             <a:prstDash val="solid"/>
           </a:ln>
@@ -7433,11 +7433,11 @@
             <a:avLst/>
           </a:prstGeom>
           <a:solidFill>
-            <a:srgbClr val="2A2A2A"/>
+            <a:srgbClr val="D6CFC4"/>
           </a:solidFill>
           <a:ln w="12700">
             <a:solidFill>
-              <a:srgbClr val="444444"/>
+              <a:srgbClr val="C0B8AA"/>
             </a:solidFill>
             <a:prstDash val="solid"/>
           </a:ln>
@@ -7458,11 +7458,11 @@
             <a:avLst/>
           </a:prstGeom>
           <a:solidFill>
-            <a:srgbClr val="000000"/>
+            <a:srgbClr val="BFB8AF"/>
           </a:solidFill>
           <a:ln w="12700">
             <a:solidFill>
-              <a:srgbClr val="000000"/>
+              <a:srgbClr val="BFB8AF"/>
             </a:solidFill>
             <a:prstDash val="solid"/>
           </a:ln>
@@ -7522,11 +7522,11 @@
             <a:avLst/>
           </a:prstGeom>
           <a:solidFill>
-            <a:srgbClr val="2A2A2A"/>
+            <a:srgbClr val="D6CFC4"/>
           </a:solidFill>
           <a:ln w="12700">
             <a:solidFill>
-              <a:srgbClr val="444444"/>
+              <a:srgbClr val="C0B8AA"/>
             </a:solidFill>
             <a:prstDash val="solid"/>
           </a:ln>
@@ -7547,11 +7547,11 @@
             <a:avLst/>
           </a:prstGeom>
           <a:solidFill>
-            <a:srgbClr val="000000"/>
+            <a:srgbClr val="BFB8AF"/>
           </a:solidFill>
           <a:ln w="12700">
             <a:solidFill>
-              <a:srgbClr val="000000"/>
+              <a:srgbClr val="BFB8AF"/>
             </a:solidFill>
             <a:prstDash val="solid"/>
           </a:ln>
@@ -8596,11 +8596,11 @@
             <a:avLst/>
           </a:prstGeom>
           <a:solidFill>
-            <a:srgbClr val="333333"/>
+            <a:srgbClr val="D6CFC4"/>
           </a:solidFill>
           <a:ln w="12700">
             <a:solidFill>
-              <a:srgbClr val="444444"/>
+              <a:srgbClr val="C0B8AA"/>
             </a:solidFill>
             <a:prstDash val="solid"/>
           </a:ln>
@@ -8827,11 +8827,11 @@
             <a:avLst/>
           </a:prstGeom>
           <a:solidFill>
-            <a:srgbClr val="333333"/>
+            <a:srgbClr val="D6CFC4"/>
           </a:solidFill>
           <a:ln w="12700">
             <a:solidFill>
-              <a:srgbClr val="444444"/>
+              <a:srgbClr val="C0B8AA"/>
             </a:solidFill>
             <a:prstDash val="solid"/>
           </a:ln>
@@ -9812,11 +9812,11 @@
             <a:avLst/>
           </a:prstGeom>
           <a:solidFill>
-            <a:srgbClr val="333333"/>
+            <a:srgbClr val="D6CFC4"/>
           </a:solidFill>
           <a:ln w="12700">
             <a:solidFill>
-              <a:srgbClr val="444444"/>
+              <a:srgbClr val="C0B8AA"/>
             </a:solidFill>
             <a:prstDash val="solid"/>
           </a:ln>
@@ -10043,11 +10043,11 @@
             <a:avLst/>
           </a:prstGeom>
           <a:solidFill>
-            <a:srgbClr val="333333"/>
+            <a:srgbClr val="D6CFC4"/>
           </a:solidFill>
           <a:ln w="12700">
             <a:solidFill>
-              <a:srgbClr val="444444"/>
+              <a:srgbClr val="C0B8AA"/>
             </a:solidFill>
             <a:prstDash val="solid"/>
           </a:ln>
@@ -11103,11 +11103,11 @@
             <a:avLst/>
           </a:prstGeom>
           <a:solidFill>
-            <a:srgbClr val="2A2A2A"/>
+            <a:srgbClr val="D6CFC4"/>
           </a:solidFill>
           <a:ln w="12700">
             <a:solidFill>
-              <a:srgbClr val="444444"/>
+              <a:srgbClr val="C0B8AA"/>
             </a:solidFill>
             <a:prstDash val="solid"/>
           </a:ln>
@@ -12035,11 +12035,11 @@
             <a:avLst/>
           </a:prstGeom>
           <a:solidFill>
-            <a:srgbClr val="2A2A2A"/>
+            <a:srgbClr val="D6CFC4"/>
           </a:solidFill>
           <a:ln w="12700">
             <a:solidFill>
-              <a:srgbClr val="444444"/>
+              <a:srgbClr val="C0B8AA"/>
             </a:solidFill>
             <a:prstDash val="solid"/>
           </a:ln>
@@ -12967,11 +12967,11 @@
             <a:avLst/>
           </a:prstGeom>
           <a:solidFill>
-            <a:srgbClr val="2A2A2A"/>
+            <a:srgbClr val="D6CFC4"/>
           </a:solidFill>
           <a:ln w="12700">
             <a:solidFill>
-              <a:srgbClr val="444444"/>
+              <a:srgbClr val="C0B8AA"/>
             </a:solidFill>
             <a:prstDash val="solid"/>
           </a:ln>

</xml_diff>